<commit_message>
Fase A: personajes más infantiles (piel ligeramente más clara), 4 hojas para colorear nuevas y materiales regenerados
- ChildGirl/ChildBoy: proporciones infantiles (cabeza mayor, cuerpo más corto), tonos de piel
  ligeramente más claros (niño más claro que niña). Mismo diseño, cabello, ropa, colores y poses.
- Hojas para colorear semanas 1-4: escenas distintas en blanco y negro, línea gruesa, ligadas a cada versículo.
- Presentaciones, hojas de trabajo, tarjetas RVR1960 y guías PDF regeneradas con los personajes ajustados.
- tools/materiales: generadores reproducibles (leen los datos de src/data; no afectan al build de la app).
</commit_message>
<xml_diff>
--- a/public/recursos-semana-1/presentacion-semana-1.pptx
+++ b/public/recursos-semana-1/presentacion-semana-1.pptx
@@ -1589,7 +1589,7 @@
       </p:grpSpPr>
       <p:pic>
         <p:nvPicPr>
-          <p:cNvPr id="2" name="Image 0" descr="/home/claude/work/r47/logo-cimiento-small.png">    </p:cNvPr>
+          <p:cNvPr id="2" name="Image 0" descr="/home/claude/work/b/cimiento-bloque1/tools/materiales/out/cache/logo-cimiento-small.png">    </p:cNvPr>
           <p:cNvPicPr>
             <a:picLocks noChangeAspect="1"/>
           </p:cNvPicPr>
@@ -1613,7 +1613,7 @@
       </p:pic>
       <p:pic>
         <p:nvPicPr>
-          <p:cNvPr id="3" name="Image 1" descr="/home/claude/work/r47/logo-ieoh-badge.png">    </p:cNvPr>
+          <p:cNvPr id="3" name="Image 1" descr="/home/claude/work/b/cimiento-bloque1/tools/materiales/out/cache/logo-ieoh-badge.png">    </p:cNvPr>
           <p:cNvPicPr>
             <a:picLocks noChangeAspect="1"/>
           </p:cNvPicPr>
@@ -1715,7 +1715,7 @@
       </p:sp>
       <p:pic>
         <p:nvPicPr>
-          <p:cNvPr id="6" name="Image 2" descr="/home/claude/work/r47/ill_sun.png">    </p:cNvPr>
+          <p:cNvPr id="6" name="Image 2" descr="/home/claude/work/b/cimiento-bloque1/tools/materiales/out/cache/ill_tree.png">    </p:cNvPr>
           <p:cNvPicPr>
             <a:picLocks noChangeAspect="1"/>
           </p:cNvPicPr>
@@ -1729,8 +1729,8 @@
         </p:blipFill>
         <p:spPr>
           <a:xfrm>
-            <a:off x="8778240" y="4206240"/>
-            <a:ext cx="1920240" cy="1920240"/>
+            <a:off x="822960" y="4114800"/>
+            <a:ext cx="2103120" cy="2103120"/>
           </a:xfrm>
           <a:prstGeom prst="rect">
             <a:avLst/>
@@ -1739,7 +1739,7 @@
       </p:pic>
       <p:pic>
         <p:nvPicPr>
-          <p:cNvPr id="7" name="Image 3" descr="/home/claude/work/r47/ill_tree.png">    </p:cNvPr>
+          <p:cNvPr id="7" name="Image 3" descr="/home/claude/work/b/cimiento-bloque1/tools/materiales/out/cache/ill_sun.png">    </p:cNvPr>
           <p:cNvPicPr>
             <a:picLocks noChangeAspect="1"/>
           </p:cNvPicPr>
@@ -1753,8 +1753,8 @@
         </p:blipFill>
         <p:spPr>
           <a:xfrm>
-            <a:off x="822960" y="4114800"/>
-            <a:ext cx="2103120" cy="2103120"/>
+            <a:off x="8778240" y="4206240"/>
+            <a:ext cx="1920240" cy="1920240"/>
           </a:xfrm>
           <a:prstGeom prst="rect">
             <a:avLst/>
@@ -1763,7 +1763,7 @@
       </p:pic>
       <p:pic>
         <p:nvPicPr>
-          <p:cNvPr id="8" name="Image 4" descr="/home/claude/work/r47/nina_wave.png">    </p:cNvPr>
+          <p:cNvPr id="8" name="Image 4" descr="/home/claude/work/b/cimiento-bloque1/tools/materiales/out/cache/nina_wave_900.png">    </p:cNvPr>
           <p:cNvPicPr>
             <a:picLocks noChangeAspect="1"/>
           </p:cNvPicPr>
@@ -1777,8 +1777,8 @@
         </p:blipFill>
         <p:spPr>
           <a:xfrm>
-            <a:off x="5029200" y="3566160"/>
-            <a:ext cx="1828800" cy="3108960"/>
+            <a:off x="5120640" y="3840480"/>
+            <a:ext cx="1764792" cy="2651760"/>
           </a:xfrm>
           <a:prstGeom prst="rect">
             <a:avLst/>
@@ -1845,7 +1845,7 @@
         </p:nvSpPr>
         <p:spPr>
           <a:xfrm>
-            <a:off x="548640" y="2103120"/>
+            <a:off x="548640" y="1828800"/>
             <a:ext cx="11064240" cy="1645920"/>
           </a:xfrm>
           <a:prstGeom prst="rect">
@@ -1878,7 +1878,7 @@
       </p:sp>
       <p:pic>
         <p:nvPicPr>
-          <p:cNvPr id="4" name="Image 0" descr="/home/claude/work/r47/nino_wave.png">    </p:cNvPr>
+          <p:cNvPr id="4" name="Image 0" descr="/home/claude/work/b/cimiento-bloque1/tools/materiales/out/cache/nino_wave_900.png">    </p:cNvPr>
           <p:cNvPicPr>
             <a:picLocks noChangeAspect="1"/>
           </p:cNvPicPr>
@@ -1892,8 +1892,8 @@
         </p:blipFill>
         <p:spPr>
           <a:xfrm>
-            <a:off x="4937760" y="2926080"/>
-            <a:ext cx="1984248" cy="3383280"/>
+            <a:off x="5029200" y="3017520"/>
+            <a:ext cx="2130552" cy="3200400"/>
           </a:xfrm>
           <a:prstGeom prst="rect">
             <a:avLst/>
@@ -2108,7 +2108,7 @@
       </p:sp>
       <p:pic>
         <p:nvPicPr>
-          <p:cNvPr id="4" name="Image 0" descr="/home/claude/work/r47/ill_sun.png">    </p:cNvPr>
+          <p:cNvPr id="4" name="Image 0" descr="/home/claude/work/b/cimiento-bloque1/tools/materiales/out/cache/ill_sun.png">    </p:cNvPr>
           <p:cNvPicPr>
             <a:picLocks noChangeAspect="1"/>
           </p:cNvPicPr>
@@ -2195,7 +2195,7 @@
       </p:sp>
       <p:pic>
         <p:nvPicPr>
-          <p:cNvPr id="7" name="Image 1" descr="/home/claude/work/r47/ill_tree.png">    </p:cNvPr>
+          <p:cNvPr id="7" name="Image 1" descr="/home/claude/work/b/cimiento-bloque1/tools/materiales/out/cache/ill_tree.png">    </p:cNvPr>
           <p:cNvPicPr>
             <a:picLocks noChangeAspect="1"/>
           </p:cNvPicPr>
@@ -2282,7 +2282,7 @@
       </p:sp>
       <p:pic>
         <p:nvPicPr>
-          <p:cNvPr id="10" name="Image 2" descr="/home/claude/work/r47/ill_bird.png">    </p:cNvPr>
+          <p:cNvPr id="10" name="Image 2" descr="/home/claude/work/b/cimiento-bloque1/tools/materiales/out/cache/ill_bird.png">    </p:cNvPr>
           <p:cNvPicPr>
             <a:picLocks noChangeAspect="1"/>
           </p:cNvPicPr>
@@ -2376,7 +2376,7 @@
       </p:grpSpPr>
       <p:pic>
         <p:nvPicPr>
-          <p:cNvPr id="2" name="Image 0" descr="/home/claude/work/r47/nina_wave.png">    </p:cNvPr>
+          <p:cNvPr id="2" name="Image 0" descr="/home/claude/work/b/cimiento-bloque1/tools/materiales/out/cache/nina_wave_900.png">    </p:cNvPr>
           <p:cNvPicPr>
             <a:picLocks noChangeAspect="1"/>
           </p:cNvPicPr>
@@ -2390,8 +2390,8 @@
         </p:blipFill>
         <p:spPr>
           <a:xfrm>
-            <a:off x="5120640" y="822960"/>
-            <a:ext cx="1691640" cy="2880360"/>
+            <a:off x="5303520" y="822960"/>
+            <a:ext cx="1947672" cy="2926080"/>
           </a:xfrm>
           <a:prstGeom prst="rect">
             <a:avLst/>
@@ -2565,24 +2565,7 @@
                 <a:ea typeface="Cambria" pitchFamily="34" charset="-122"/>
                 <a:cs typeface="Cambria" pitchFamily="34" charset="-120"/>
               </a:rPr>
-              <a:t>¿Qué cosas hizo Dios</a:t>
-            </a:r>
-            <a:endParaRPr lang="en-US" sz="3200" dirty="0"/>
-          </a:p>
-          <a:p>
-            <a:pPr algn="ctr" indent="0" marL="0">
-              <a:buNone/>
-            </a:pPr>
-            <a:r>
-              <a:rPr lang="en-US" sz="3200" b="1" dirty="0">
-                <a:solidFill>
-                  <a:srgbClr val="0E2338"/>
-                </a:solidFill>
-                <a:latin typeface="Cambria" pitchFamily="34" charset="0"/>
-                <a:ea typeface="Cambria" pitchFamily="34" charset="-122"/>
-                <a:cs typeface="Cambria" pitchFamily="34" charset="-120"/>
-              </a:rPr>
-              <a:t>que puedes ver ahora mismo?</a:t>
+              <a:t>¿Qué cosas hizo Dios que puedes ver ahora mismo?</a:t>
             </a:r>
             <a:endParaRPr lang="en-US" sz="3200" dirty="0"/>
           </a:p>
@@ -2884,32 +2867,15 @@
                 <a:ea typeface="Calibri" pitchFamily="34" charset="-122"/>
                 <a:cs typeface="Calibri" pitchFamily="34" charset="-120"/>
               </a:rPr>
-              <a:t>Dibuja algo que Dios hizo,</a:t>
+              <a:t>Dibuja algo que Dios hizo, y algo que Dios te dio a ti.</a:t>
             </a:r>
             <a:endParaRPr lang="en-US" sz="2600" dirty="0"/>
           </a:p>
-          <a:p>
-            <a:pPr algn="ctr" indent="0" marL="0">
-              <a:buNone/>
-            </a:pPr>
-            <a:r>
-              <a:rPr lang="en-US" sz="2600" dirty="0">
-                <a:solidFill>
-                  <a:srgbClr val="0E2338"/>
-                </a:solidFill>
-                <a:latin typeface="Calibri" pitchFamily="34" charset="0"/>
-                <a:ea typeface="Calibri" pitchFamily="34" charset="-122"/>
-                <a:cs typeface="Calibri" pitchFamily="34" charset="-120"/>
-              </a:rPr>
-              <a:t>y algo que Dios te dio a ti.</a:t>
-            </a:r>
-            <a:endParaRPr lang="en-US" sz="2600" dirty="0"/>
-          </a:p>
         </p:txBody>
       </p:sp>
       <p:pic>
         <p:nvPicPr>
-          <p:cNvPr id="5" name="Image 0" descr="/home/claude/work/r47/nino_wave.png">    </p:cNvPr>
+          <p:cNvPr id="5" name="Image 0" descr="/home/claude/work/b/cimiento-bloque1/tools/materiales/out/cache/nino_wave_900.png">    </p:cNvPr>
           <p:cNvPicPr>
             <a:picLocks noChangeAspect="1"/>
           </p:cNvPicPr>
@@ -2923,8 +2889,8 @@
         </p:blipFill>
         <p:spPr>
           <a:xfrm>
-            <a:off x="548640" y="4206240"/>
-            <a:ext cx="1289304" cy="2194560"/>
+            <a:off x="548640" y="4297680"/>
+            <a:ext cx="1463040" cy="2194560"/>
           </a:xfrm>
           <a:prstGeom prst="rect">
             <a:avLst/>
@@ -2933,7 +2899,7 @@
       </p:pic>
       <p:pic>
         <p:nvPicPr>
-          <p:cNvPr id="6" name="Image 1" descr="/home/claude/work/r47/ill_tree.png">    </p:cNvPr>
+          <p:cNvPr id="6" name="Image 1" descr="/home/claude/work/b/cimiento-bloque1/tools/materiales/out/cache/ill_tree.png">    </p:cNvPr>
           <p:cNvPicPr>
             <a:picLocks noChangeAspect="1"/>
           </p:cNvPicPr>
@@ -2989,7 +2955,7 @@
       </p:grpSpPr>
       <p:pic>
         <p:nvPicPr>
-          <p:cNvPr id="2" name="Image 0" descr="/home/claude/work/r47/logo-cimiento-small.png">    </p:cNvPr>
+          <p:cNvPr id="2" name="Image 0" descr="/home/claude/work/b/cimiento-bloque1/tools/materiales/out/cache/logo-cimiento-small.png">    </p:cNvPr>
           <p:cNvPicPr>
             <a:picLocks noChangeAspect="1"/>
           </p:cNvPicPr>
@@ -3013,7 +2979,7 @@
       </p:pic>
       <p:pic>
         <p:nvPicPr>
-          <p:cNvPr id="3" name="Image 1" descr="/home/claude/work/r47/logo-ieoh-badge.png">    </p:cNvPr>
+          <p:cNvPr id="3" name="Image 1" descr="/home/claude/work/b/cimiento-bloque1/tools/materiales/out/cache/logo-ieoh-badge.png">    </p:cNvPr>
           <p:cNvPicPr>
             <a:picLocks noChangeAspect="1"/>
           </p:cNvPicPr>
@@ -3068,24 +3034,7 @@
                 <a:ea typeface="Cambria" pitchFamily="34" charset="-122"/>
                 <a:cs typeface="Cambria" pitchFamily="34" charset="-120"/>
               </a:rPr>
-              <a:t>Gracias, Dios,</a:t>
-            </a:r>
-            <a:endParaRPr lang="en-US" sz="4200" dirty="0"/>
-          </a:p>
-          <a:p>
-            <a:pPr algn="ctr" indent="0" marL="0">
-              <a:buNone/>
-            </a:pPr>
-            <a:r>
-              <a:rPr lang="en-US" sz="4200" b="1" dirty="0">
-                <a:solidFill>
-                  <a:srgbClr val="FDFCFA"/>
-                </a:solidFill>
-                <a:latin typeface="Cambria" pitchFamily="34" charset="0"/>
-                <a:ea typeface="Cambria" pitchFamily="34" charset="-122"/>
-                <a:cs typeface="Cambria" pitchFamily="34" charset="-120"/>
-              </a:rPr>
-              <a:t>porque tú me hiciste.</a:t>
+              <a:t>Gracias, Dios, porque tú me hiciste.</a:t>
             </a:r>
             <a:endParaRPr lang="en-US" sz="4200" dirty="0"/>
           </a:p>

</xml_diff>